<commit_message>
Manager decks: layout fixes on the ABL numbers slide and i-STAT title
Co-Authored-By: Claude Fable 5.1 <noreply@anthropic.com>
</commit_message>
<xml_diff>
--- a/PQ_Report_Generator_Overview_for_Managers_ABL.pptx
+++ b/PQ_Report_Generator_Overview_for_Managers_ABL.pptx
@@ -2619,8 +2619,8 @@
         </p:blipFill>
         <p:spPr>
           <a:xfrm>
-            <a:off x="6766560" y="1188720"/>
-            <a:ext cx="3429521" cy="4846320"/>
+            <a:off x="7589520" y="2606040"/>
+            <a:ext cx="2361840" cy="3337560"/>
           </a:xfrm>
           <a:prstGeom prst="rect">
             <a:avLst/>
@@ -2640,8 +2640,8 @@
         </p:nvSpPr>
         <p:spPr>
           <a:xfrm>
-            <a:off x="6766560" y="6080759"/>
-            <a:ext cx="3429521" cy="365760"/>
+            <a:off x="7589520" y="5989320"/>
+            <a:ext cx="2361840" cy="365760"/>
           </a:xfrm>
           <a:prstGeom prst="rect">
             <a:avLst/>

</xml_diff>

<commit_message>
Demo examples now carry a full 12 months on every chart (i-STAT and ABL)
i-STAT demo sandbox backfilled month by month from de-identified exports
(Sep 2025 - Aug 2026, consistent synthetic names across months); ABL demo
run through twelve synthetic months with a stable operator roster.

Co-Authored-By: Claude Fable 5.1 <noreply@anthropic.com>
</commit_message>
<xml_diff>
--- a/PQ_Report_Generator_Overview_for_Managers_ABL.pptx
+++ b/PQ_Report_Generator_Overview_for_Managers_ABL.pptx
@@ -1806,7 +1806,7 @@
                   <a:srgbClr val="01485C"/>
                 </a:solidFill>
               </a:rPr>
-              <a:t>52</a:t>
+              <a:t>54</a:t>
             </a:r>
           </a:p>
         </p:txBody>
@@ -2052,7 +2052,7 @@
                   <a:srgbClr val="01485C"/>
                 </a:solidFill>
               </a:rPr>
-              <a:t>68</a:t>
+              <a:t>70</a:t>
             </a:r>
           </a:p>
         </p:txBody>
@@ -2447,7 +2447,7 @@
                   <a:srgbClr val="17272E"/>
                 </a:solidFill>
               </a:rPr>
-              <a:t>RBWH\   9 documents</a:t>
+              <a:t>RBWH\   10 documents</a:t>
             </a:r>
           </a:p>
           <a:p>
@@ -2530,7 +2530,7 @@
                   <a:srgbClr val="17272E"/>
                 </a:solidFill>
               </a:rPr>
-              <a:t>Mount_Isa\   3 documents</a:t>
+              <a:t>Mount_Isa\   4 documents</a:t>
             </a:r>
           </a:p>
           <a:p>

</xml_diff>

<commit_message>
Decks: repair files PowerPoint refused (negative text-box width on the page-6 slide; duplicate shape ids on the guide slide)
Co-Authored-By: Claude Fable 5.1 <noreply@anthropic.com>
</commit_message>
<xml_diff>
--- a/PQ_Report_Generator_Overview_for_Managers_ABL.pptx
+++ b/PQ_Report_Generator_Overview_for_Managers_ABL.pptx
@@ -3973,7 +3973,7 @@
         <p:spPr>
           <a:xfrm>
             <a:off x="548640" y="1143000"/>
-            <a:ext cx="7798985" cy="4846320"/>
+            <a:ext cx="6949440" cy="4318409"/>
           </a:xfrm>
           <a:prstGeom prst="rect">
             <a:avLst/>
@@ -3993,8 +3993,8 @@
         </p:nvSpPr>
         <p:spPr>
           <a:xfrm>
-            <a:off x="548640" y="6035040"/>
-            <a:ext cx="7798984" cy="365760"/>
+            <a:off x="548640" y="5507129"/>
+            <a:ext cx="6949440" cy="365760"/>
           </a:xfrm>
           <a:prstGeom prst="rect">
             <a:avLst/>
@@ -4031,8 +4031,8 @@
         </p:nvSpPr>
         <p:spPr>
           <a:xfrm>
-            <a:off x="8667664" y="1188720"/>
-            <a:ext cx="2945215" cy="4846320"/>
+            <a:off x="7818119" y="1188720"/>
+            <a:ext cx="3794760" cy="4846320"/>
           </a:xfrm>
           <a:prstGeom prst="rect">
             <a:avLst/>

</xml_diff>

<commit_message>
Credit lines: both names at the same size
Co-Authored-By: Claude Fable 5.1 <noreply@anthropic.com>
</commit_message>
<xml_diff>
--- a/PQ_Report_Generator_Overview_for_Managers_ABL.pptx
+++ b/PQ_Report_Generator_Overview_for_Managers_ABL.pptx
@@ -1214,7 +1214,7 @@
           <a:p>
             <a:pPr/>
             <a:r>
-              <a:rPr sz="1000">
+              <a:rPr sz="1100">
                 <a:solidFill>
                   <a:srgbClr val="6CCAD4"/>
                 </a:solidFill>
@@ -2725,7 +2725,7 @@
               </a:spcAft>
             </a:pPr>
             <a:r>
-              <a:rPr sz="1000" b="0">
+              <a:rPr sz="1100" b="0">
                 <a:solidFill>
                   <a:srgbClr val="5F7178"/>
                 </a:solidFill>
@@ -3241,7 +3241,7 @@
               </a:spcAft>
             </a:pPr>
             <a:r>
-              <a:rPr sz="1000" b="0">
+              <a:rPr sz="1100" b="0">
                 <a:solidFill>
                   <a:srgbClr val="5F7178"/>
                 </a:solidFill>
@@ -3757,7 +3757,7 @@
               </a:spcAft>
             </a:pPr>
             <a:r>
-              <a:rPr sz="1000" b="0">
+              <a:rPr sz="1100" b="0">
                 <a:solidFill>
                   <a:srgbClr val="5F7178"/>
                 </a:solidFill>
@@ -4206,7 +4206,7 @@
               </a:spcAft>
             </a:pPr>
             <a:r>
-              <a:rPr sz="1000" b="0">
+              <a:rPr sz="1100" b="0">
                 <a:solidFill>
                   <a:srgbClr val="5F7178"/>
                 </a:solidFill>
@@ -4670,7 +4670,7 @@
               </a:spcAft>
             </a:pPr>
             <a:r>
-              <a:rPr sz="1000" b="0">
+              <a:rPr sz="1100" b="0">
                 <a:solidFill>
                   <a:srgbClr val="5F7178"/>
                 </a:solidFill>
@@ -5440,7 +5440,7 @@
               </a:spcAft>
             </a:pPr>
             <a:r>
-              <a:rPr sz="1000" b="0">
+              <a:rPr sz="1100" b="0">
                 <a:solidFill>
                   <a:srgbClr val="5F7178"/>
                 </a:solidFill>
@@ -6210,7 +6210,7 @@
               </a:spcAft>
             </a:pPr>
             <a:r>
-              <a:rPr sz="1000" b="0">
+              <a:rPr sz="1100" b="0">
                 <a:solidFill>
                   <a:srgbClr val="5F7178"/>
                 </a:solidFill>

</xml_diff>